<commit_message>
v3.18.0 : « chef de groupe » devient « responsable d'équipe » partout ; nouveautés traduites
Co-Authored-By: Claude Sonnet 5.5 <noreply@anthropic.com>
Claude-Session: https://claude.ai/code/session_01X2N9yuBhmf2MHQAUEM1VoV
</commit_message>
<xml_diff>
--- a/Kit-Sijil/Sijil-Presentation.pptx
+++ b/Kit-Sijil/Sijil-Presentation.pptx
@@ -3352,7 +3352,7 @@
                 </a:solidFill>
                 <a:latin typeface="Calibri"/>
               </a:rPr>
-              <a:t>Version 3.17 · Octobre 2026 · Captures : entreprise fictive</a:t>
+              <a:t>Version 3.18 · Octobre 2026 · Captures : entreprise fictive</a:t>
             </a:r>
           </a:p>
         </p:txBody>
@@ -5048,7 +5048,7 @@
                 </a:solidFill>
                 <a:latin typeface="Calibri"/>
               </a:rPr>
-              <a:t> — et e-mail au chef de groupe</a:t>
+              <a:t> — et e-mail au responsable d’équipe</a:t>
             </a:r>
           </a:p>
           <a:p>
@@ -5528,7 +5528,7 @@
                 </a:solidFill>
                 <a:latin typeface="Calibri"/>
               </a:rPr>
-              <a:t>Le chef de groupe est prévenu avec les dates et la date de reprise.</a:t>
+              <a:t>Le responsable d’équipe est prévenu avec les dates et la date de reprise.</a:t>
             </a:r>
           </a:p>
         </p:txBody>
@@ -5646,7 +5646,7 @@
                 </a:solidFill>
                 <a:latin typeface="Calibri"/>
               </a:rPr>
-              <a:t>Le chef de groupe voit la pastille et reçoit la remarque du client.</a:t>
+              <a:t>Le responsable d’équipe voit la pastille et reçoit la remarque du client.</a:t>
             </a:r>
           </a:p>
         </p:txBody>
@@ -9201,7 +9201,7 @@
                 </a:solidFill>
                 <a:latin typeface="Calibri"/>
               </a:rPr>
-              <a:t>Chaque agent écrit à son chef, qui relaie à la direction, sans suivi.</a:t>
+              <a:t>Chaque agent écrit à son responsable, qui relaie à la direction, sans suivi.</a:t>
             </a:r>
           </a:p>
         </p:txBody>
@@ -11105,7 +11105,7 @@
                 </a:solidFill>
                 <a:latin typeface="Calibri"/>
               </a:rPr>
-              <a:t>Le chef de groupe</a:t>
+              <a:t>Le responsable d’équipe</a:t>
             </a:r>
           </a:p>
         </p:txBody>

</xml_diff>

<commit_message>
v3.33.0 : signature JawlaDev partout (pied de page, accueil, confidentialité, e-mails, manuel, présentation) avec lien vers le portfolio
Co-Authored-By: Claude Sonnet 5.5 <noreply@anthropic.com>
Claude-Session: https://claude.ai/code/session_01X2N9yuBhmf2MHQAUEM1VoV
</commit_message>
<xml_diff>
--- a/Kit-Sijil/Sijil-Presentation.pptx
+++ b/Kit-Sijil/Sijil-Presentation.pptx
@@ -3352,7 +3352,7 @@
                 </a:solidFill>
                 <a:latin typeface="Calibri"/>
               </a:rPr>
-              <a:t>Version 3.25.1 · Octobre 2026 · Captures : entreprise fictive</a:t>
+              <a:t>Version 3.32.1 · Octobre 2026 · Captures : entreprise fictive</a:t>
             </a:r>
           </a:p>
         </p:txBody>
@@ -3562,7 +3562,7 @@
                 </a:solidFill>
                 <a:latin typeface="Calibri"/>
               </a:rPr>
-              <a:t>© 2026 Rayane M. — Tous droits réservés</a:t>
+              <a:t>© 2026 JawlaDev — Tous droits réservés</a:t>
             </a:r>
           </a:p>
         </p:txBody>
@@ -4012,7 +4012,7 @@
                 </a:solidFill>
                 <a:latin typeface="Calibri"/>
               </a:rPr>
-              <a:t>© 2026 Rayane M. — Tous droits réservés</a:t>
+              <a:t>© 2026 JawlaDev — Tous droits réservés</a:t>
             </a:r>
           </a:p>
         </p:txBody>
@@ -4410,7 +4410,7 @@
                 </a:solidFill>
                 <a:latin typeface="Calibri"/>
               </a:rPr>
-              <a:t>© 2026 Rayane M. — Tous droits réservés</a:t>
+              <a:t>© 2026 JawlaDev — Tous droits réservés</a:t>
             </a:r>
           </a:p>
         </p:txBody>
@@ -4842,7 +4842,7 @@
                 </a:solidFill>
                 <a:latin typeface="Calibri"/>
               </a:rPr>
-              <a:t>© 2026 Rayane M. — Tous droits réservés</a:t>
+              <a:t>© 2026 JawlaDev — Tous droits réservés</a:t>
             </a:r>
           </a:p>
         </p:txBody>
@@ -5292,7 +5292,7 @@
                 </a:solidFill>
                 <a:latin typeface="Calibri"/>
               </a:rPr>
-              <a:t>© 2026 Rayane M. — Tous droits réservés</a:t>
+              <a:t>© 2026 JawlaDev — Tous droits réservés</a:t>
             </a:r>
           </a:p>
         </p:txBody>
@@ -6092,7 +6092,7 @@
                 </a:solidFill>
                 <a:latin typeface="Calibri"/>
               </a:rPr>
-              <a:t>© 2026 Rayane M. — Tous droits réservés</a:t>
+              <a:t>© 2026 JawlaDev — Tous droits réservés</a:t>
             </a:r>
           </a:p>
         </p:txBody>
@@ -6407,7 +6407,7 @@
                 </a:solidFill>
                 <a:latin typeface="Calibri"/>
               </a:rPr>
-              <a:t>© 2026 Rayane M. — Tous droits réservés</a:t>
+              <a:t>© 2026 JawlaDev — Tous droits réservés</a:t>
             </a:r>
           </a:p>
         </p:txBody>
@@ -6907,7 +6907,7 @@
                 </a:solidFill>
                 <a:latin typeface="Calibri"/>
               </a:rPr>
-              <a:t>© 2026 Rayane M. — Tous droits réservés</a:t>
+              <a:t>© 2026 JawlaDev — Tous droits réservés</a:t>
             </a:r>
           </a:p>
         </p:txBody>
@@ -7786,7 +7786,7 @@
                 </a:solidFill>
                 <a:latin typeface="Calibri"/>
               </a:rPr>
-              <a:t>© 2026 Rayane M. — Tous droits réservés</a:t>
+              <a:t>© 2026 JawlaDev — Tous droits réservés</a:t>
             </a:r>
           </a:p>
         </p:txBody>
@@ -8401,7 +8401,7 @@
                 </a:solidFill>
                 <a:latin typeface="Calibri"/>
               </a:rPr>
-              <a:t>© 2026 Rayane M. — Tous droits réservés</a:t>
+              <a:t>© 2026 JawlaDev — Tous droits réservés</a:t>
             </a:r>
           </a:p>
         </p:txBody>
@@ -8611,7 +8611,7 @@
                 </a:solidFill>
                 <a:latin typeface="Calibri"/>
               </a:rPr>
-              <a:t>© 2026 Rayane M. — Tous droits réservés</a:t>
+              <a:t>© 2026 JawlaDev — Tous droits réservés</a:t>
             </a:r>
           </a:p>
         </p:txBody>
@@ -9529,7 +9529,7 @@
                 </a:solidFill>
                 <a:latin typeface="Calibri"/>
               </a:rPr>
-              <a:t>© 2026 Rayane M. — Tous droits réservés</a:t>
+              <a:t>© 2026 JawlaDev — Tous droits réservés</a:t>
             </a:r>
           </a:p>
         </p:txBody>
@@ -9927,7 +9927,7 @@
                 </a:solidFill>
                 <a:latin typeface="Calibri"/>
               </a:rPr>
-              <a:t>© 2026 Rayane M. — Tous droits réservés</a:t>
+              <a:t>© 2026 JawlaDev — Tous droits réservés</a:t>
             </a:r>
           </a:p>
         </p:txBody>
@@ -10868,7 +10868,7 @@
                 </a:solidFill>
                 <a:latin typeface="Calibri"/>
               </a:rPr>
-              <a:t>© 2026 Rayane M. — Tous droits réservés</a:t>
+              <a:t>© 2026 JawlaDev — Tous droits réservés</a:t>
             </a:r>
           </a:p>
         </p:txBody>
@@ -11694,7 +11694,7 @@
                 </a:solidFill>
                 <a:latin typeface="Calibri"/>
               </a:rPr>
-              <a:t>© 2026 Rayane M. — Tous droits réservés</a:t>
+              <a:t>© 2026 JawlaDev — Tous droits réservés</a:t>
             </a:r>
           </a:p>
         </p:txBody>
@@ -12092,7 +12092,7 @@
                 </a:solidFill>
                 <a:latin typeface="Calibri"/>
               </a:rPr>
-              <a:t>© 2026 Rayane M. — Tous droits réservés</a:t>
+              <a:t>© 2026 JawlaDev — Tous droits réservés</a:t>
             </a:r>
           </a:p>
         </p:txBody>
@@ -12490,7 +12490,7 @@
                 </a:solidFill>
                 <a:latin typeface="Calibri"/>
               </a:rPr>
-              <a:t>© 2026 Rayane M. — Tous droits réservés</a:t>
+              <a:t>© 2026 JawlaDev — Tous droits réservés</a:t>
             </a:r>
           </a:p>
         </p:txBody>
@@ -12888,7 +12888,7 @@
                 </a:solidFill>
                 <a:latin typeface="Calibri"/>
               </a:rPr>
-              <a:t>© 2026 Rayane M. — Tous droits réservés</a:t>
+              <a:t>© 2026 JawlaDev — Tous droits réservés</a:t>
             </a:r>
           </a:p>
         </p:txBody>

</xml_diff>

<commit_message>
v3.41.0 : module Facturation activable par l'administrateur ; kit commercial mis à jour (rotations, personnel et matériel, de A à Z)
Co-Authored-By: Claude Sonnet 5.5 <noreply@anthropic.com>
Claude-Session: https://claude.ai/code/session_01X2N9yuBhmf2MHQAUEM1VoV
</commit_message>
<xml_diff>
--- a/Kit-Sijil/Sijil-Presentation.pptx
+++ b/Kit-Sijil/Sijil-Presentation.pptx
@@ -3225,8 +3225,8 @@
         </p:nvSpPr>
         <p:spPr>
           <a:xfrm>
-            <a:off x="5120640" y="1737360"/>
-            <a:ext cx="6583680" cy="1280160"/>
+            <a:off x="5120640" y="1463040"/>
+            <a:ext cx="6583680" cy="1463040"/>
           </a:xfrm>
           <a:prstGeom prst="rect">
             <a:avLst/>
@@ -3260,8 +3260,8 @@
         </p:nvSpPr>
         <p:spPr>
           <a:xfrm>
-            <a:off x="5120640" y="3246120"/>
-            <a:ext cx="6400800" cy="1097280"/>
+            <a:off x="5120640" y="2743200"/>
+            <a:ext cx="6583680" cy="457200"/>
           </a:xfrm>
           <a:prstGeom prst="rect">
             <a:avLst/>
@@ -3276,13 +3276,13 @@
           <a:p>
             <a:pPr algn="l"/>
             <a:r>
-              <a:rPr sz="2000" b="0" i="0">
-                <a:solidFill>
-                  <a:srgbClr val="12263A"/>
-                </a:solidFill>
-                <a:latin typeface="Calibri"/>
-              </a:rPr>
-              <a:t>La mise à disposition et le personnel de prestation de services, de A à Z : du bordereau des prix jusqu'à l'attachement et à la facture.</a:t>
+              <a:rPr sz="2000" b="1" i="0">
+                <a:solidFill>
+                  <a:srgbClr val="2FB5B4"/>
+                </a:solidFill>
+                <a:latin typeface="Calibri"/>
+              </a:rPr>
+              <a:t>avec prise en charge des rotations</a:t>
             </a:r>
           </a:p>
         </p:txBody>
@@ -3295,8 +3295,8 @@
         </p:nvSpPr>
         <p:spPr>
           <a:xfrm>
-            <a:off x="5120640" y="4937760"/>
-            <a:ext cx="6400800" cy="457200"/>
+            <a:off x="5120640" y="3383280"/>
+            <a:ext cx="6400800" cy="1280160"/>
           </a:xfrm>
           <a:prstGeom prst="rect">
             <a:avLst/>
@@ -3311,13 +3311,13 @@
           <a:p>
             <a:pPr algn="l"/>
             <a:r>
-              <a:rPr sz="1600" b="1" i="0">
-                <a:solidFill>
-                  <a:srgbClr val="16598D"/>
-                </a:solidFill>
-                <a:latin typeface="Calibri"/>
-              </a:rPr>
-              <a:t>En français, en arabe et en anglais · sur ordinateur et sur téléphone</a:t>
+              <a:rPr sz="1800" b="0" i="0">
+                <a:solidFill>
+                  <a:srgbClr val="12263A"/>
+                </a:solidFill>
+                <a:latin typeface="Calibri"/>
+              </a:rPr>
+              <a:t>La mise à disposition du personnel et du matériel de prestation de services, de A à Z : du bordereau des prix jusqu'à l'attachement et à la facture (module facturation activable par l'administrateur).</a:t>
             </a:r>
           </a:p>
         </p:txBody>
@@ -3330,8 +3330,8 @@
         </p:nvSpPr>
         <p:spPr>
           <a:xfrm>
-            <a:off x="5120640" y="6035040"/>
-            <a:ext cx="6400800" cy="365760"/>
+            <a:off x="5120640" y="4937760"/>
+            <a:ext cx="6400800" cy="457200"/>
           </a:xfrm>
           <a:prstGeom prst="rect">
             <a:avLst/>
@@ -3346,13 +3346,48 @@
           <a:p>
             <a:pPr algn="l"/>
             <a:r>
+              <a:rPr sz="1600" b="1" i="0">
+                <a:solidFill>
+                  <a:srgbClr val="16598D"/>
+                </a:solidFill>
+                <a:latin typeface="Calibri"/>
+              </a:rPr>
+              <a:t>En français, en arabe et en anglais · sur ordinateur et sur téléphone</a:t>
+            </a:r>
+          </a:p>
+        </p:txBody>
+      </p:sp>
+      <p:sp>
+        <p:nvSpPr>
+          <p:cNvPr id="9" name="TextBox 8"/>
+          <p:cNvSpPr txBox="1"/>
+          <p:nvPr/>
+        </p:nvSpPr>
+        <p:spPr>
+          <a:xfrm>
+            <a:off x="5120640" y="6035040"/>
+            <a:ext cx="6400800" cy="365760"/>
+          </a:xfrm>
+          <a:prstGeom prst="rect">
+            <a:avLst/>
+          </a:prstGeom>
+          <a:noFill/>
+        </p:spPr>
+        <p:txBody>
+          <a:bodyPr wrap="square" anchor="t" lIns="45720" rIns="45720" tIns="27432" bIns="27432">
+            <a:spAutoFit/>
+          </a:bodyPr>
+          <a:lstStyle/>
+          <a:p>
+            <a:pPr algn="l"/>
+            <a:r>
               <a:rPr sz="1100" b="0" i="0">
                 <a:solidFill>
                   <a:srgbClr val="6B7785"/>
                 </a:solidFill>
                 <a:latin typeface="Calibri"/>
               </a:rPr>
-              <a:t>Version 3.32.1 · Octobre 2026 · Captures : entreprise fictive</a:t>
+              <a:t>Version 3.41.0 · Octobre 2026 · Captures : entreprise fictive</a:t>
             </a:r>
           </a:p>
         </p:txBody>
@@ -8331,7 +8366,7 @@
                 </a:solidFill>
                 <a:latin typeface="Calibri"/>
               </a:rPr>
-              <a:t>Gestion du temps de travail</a:t>
+              <a:t>Gestion du temps de travail et des rotations</a:t>
             </a:r>
           </a:p>
         </p:txBody>
@@ -9892,7 +9927,7 @@
                 </a:solidFill>
                 <a:latin typeface="Calibri"/>
               </a:rPr>
-              <a:t>Sijil gère la mise à disposition et le personnel de prestation de services de bout en bout</a:t>
+              <a:t>Sijil gère la mise à disposition du personnel et du matériel de prestation de services, avec les rotations, de bout en bout</a:t>
             </a:r>
           </a:p>
         </p:txBody>

</xml_diff>